<commit_message>
Update financial model with realistic costs
- Claude API with caching: $0.01 per analysis (24 ₽/month)
- DaData: 54,000 ₽/year (~3 ₽ per user)
- Hosting: 6,000 ₽/year (~0.32 ₽ per user)
- Payment processing + support: 80 ₽/month
- Revised margins: 98.6% gross, 94.6% operating

https://claude.ai/code/session_012rfjEWgswWzJW42UVPNrm7
</commit_message>
<xml_diff>
--- a/presentations/01_Бизнес_презентация_Юрист2.0.pptx
+++ b/presentations/01_Бизнес_презентация_Юрист2.0.pptx
@@ -24602,7 +24602,7 @@
         <p:spPr>
           <a:xfrm>
             <a:off x="822960" y="2560320"/>
-            <a:ext cx="3200400" cy="457200"/>
+            <a:ext cx="3200400" cy="411480"/>
           </a:xfrm>
           <a:prstGeom prst="rect">
             <a:avLst/>
@@ -24617,7 +24617,7 @@
           <a:p>
             <a:pPr algn="l"/>
             <a:r>
-              <a:rPr sz="1300" b="0">
+              <a:rPr sz="1200" b="0">
                 <a:solidFill>
                   <a:srgbClr val="1A1A2E"/>
                 </a:solidFill>
@@ -24637,7 +24637,7 @@
         <p:spPr>
           <a:xfrm>
             <a:off x="4023360" y="2560320"/>
-            <a:ext cx="1828800" cy="457200"/>
+            <a:ext cx="1828800" cy="411480"/>
           </a:xfrm>
           <a:prstGeom prst="rect">
             <a:avLst/>
@@ -24652,7 +24652,7 @@
           <a:p>
             <a:pPr algn="r"/>
             <a:r>
-              <a:rPr sz="1500" b="1">
+              <a:rPr sz="1400" b="1">
                 <a:solidFill>
                   <a:srgbClr val="10B981"/>
                 </a:solidFill>
@@ -24671,8 +24671,8 @@
         </p:nvSpPr>
         <p:spPr>
           <a:xfrm>
-            <a:off x="822960" y="3108960"/>
-            <a:ext cx="3200400" cy="457200"/>
+            <a:off x="822960" y="3063240"/>
+            <a:ext cx="3200400" cy="411480"/>
           </a:xfrm>
           <a:prstGeom prst="rect">
             <a:avLst/>
@@ -24687,7 +24687,7 @@
           <a:p>
             <a:pPr algn="l"/>
             <a:r>
-              <a:rPr sz="1300" b="0">
+              <a:rPr sz="1200" b="0">
                 <a:solidFill>
                   <a:srgbClr val="1A1A2E"/>
                 </a:solidFill>
@@ -24706,8 +24706,8 @@
         </p:nvSpPr>
         <p:spPr>
           <a:xfrm>
-            <a:off x="4023360" y="3108960"/>
-            <a:ext cx="1828800" cy="457200"/>
+            <a:off x="4023360" y="3063240"/>
+            <a:ext cx="1828800" cy="411480"/>
           </a:xfrm>
           <a:prstGeom prst="rect">
             <a:avLst/>
@@ -24722,7 +24722,7 @@
           <a:p>
             <a:pPr algn="r"/>
             <a:r>
-              <a:rPr sz="1500" b="1">
+              <a:rPr sz="1400" b="1">
                 <a:solidFill>
                   <a:srgbClr val="1A1A2E"/>
                 </a:solidFill>
@@ -24741,8 +24741,8 @@
         </p:nvSpPr>
         <p:spPr>
           <a:xfrm>
-            <a:off x="822960" y="3657600"/>
-            <a:ext cx="3200400" cy="457200"/>
+            <a:off x="822960" y="3566160"/>
+            <a:ext cx="3200400" cy="411480"/>
           </a:xfrm>
           <a:prstGeom prst="rect">
             <a:avLst/>
@@ -24757,7 +24757,7 @@
           <a:p>
             <a:pPr algn="l"/>
             <a:r>
-              <a:rPr sz="1300" b="0">
+              <a:rPr sz="1200" b="0">
                 <a:solidFill>
                   <a:srgbClr val="1A1A2E"/>
                 </a:solidFill>
@@ -24776,8 +24776,8 @@
         </p:nvSpPr>
         <p:spPr>
           <a:xfrm>
-            <a:off x="4023360" y="3657600"/>
-            <a:ext cx="1828800" cy="457200"/>
+            <a:off x="4023360" y="3566160"/>
+            <a:ext cx="1828800" cy="411480"/>
           </a:xfrm>
           <a:prstGeom prst="rect">
             <a:avLst/>
@@ -24792,7 +24792,7 @@
           <a:p>
             <a:pPr algn="r"/>
             <a:r>
-              <a:rPr sz="1500" b="1">
+              <a:rPr sz="1400" b="1">
                 <a:solidFill>
                   <a:srgbClr val="10B981"/>
                 </a:solidFill>
@@ -24811,8 +24811,8 @@
         </p:nvSpPr>
         <p:spPr>
           <a:xfrm>
-            <a:off x="822960" y="4206240"/>
-            <a:ext cx="3200400" cy="457200"/>
+            <a:off x="822960" y="4069080"/>
+            <a:ext cx="3200400" cy="411480"/>
           </a:xfrm>
           <a:prstGeom prst="rect">
             <a:avLst/>
@@ -24827,7 +24827,7 @@
           <a:p>
             <a:pPr algn="l"/>
             <a:r>
-              <a:rPr sz="1300" b="0">
+              <a:rPr sz="1200" b="0">
                 <a:solidFill>
                   <a:srgbClr val="1A1A2E"/>
                 </a:solidFill>
@@ -24846,8 +24846,8 @@
         </p:nvSpPr>
         <p:spPr>
           <a:xfrm>
-            <a:off x="4023360" y="4206240"/>
-            <a:ext cx="1828800" cy="457200"/>
+            <a:off x="4023360" y="4069080"/>
+            <a:ext cx="1828800" cy="411480"/>
           </a:xfrm>
           <a:prstGeom prst="rect">
             <a:avLst/>
@@ -24862,7 +24862,7 @@
           <a:p>
             <a:pPr algn="r"/>
             <a:r>
-              <a:rPr sz="1500" b="1">
+              <a:rPr sz="1400" b="1">
                 <a:solidFill>
                   <a:srgbClr val="D4AF37"/>
                 </a:solidFill>
@@ -24881,8 +24881,8 @@
         </p:nvSpPr>
         <p:spPr>
           <a:xfrm>
-            <a:off x="822960" y="4754880"/>
-            <a:ext cx="3200400" cy="457200"/>
+            <a:off x="822960" y="4572000"/>
+            <a:ext cx="3200400" cy="411480"/>
           </a:xfrm>
           <a:prstGeom prst="rect">
             <a:avLst/>
@@ -24897,13 +24897,13 @@
           <a:p>
             <a:pPr algn="l"/>
             <a:r>
-              <a:rPr sz="1300" b="0">
+              <a:rPr sz="1200" b="0">
                 <a:solidFill>
                   <a:srgbClr val="1A1A2E"/>
                 </a:solidFill>
                 <a:latin typeface="Calibri"/>
               </a:rPr>
-              <a:t>Маржа после AI-затрат</a:t>
+              <a:t>Валовая маржа (после AI)</a:t>
             </a:r>
           </a:p>
         </p:txBody>
@@ -24916,8 +24916,8 @@
         </p:nvSpPr>
         <p:spPr>
           <a:xfrm>
-            <a:off x="4023360" y="4754880"/>
-            <a:ext cx="1828800" cy="457200"/>
+            <a:off x="4023360" y="4572000"/>
+            <a:ext cx="1828800" cy="411480"/>
           </a:xfrm>
           <a:prstGeom prst="rect">
             <a:avLst/>
@@ -24932,13 +24932,13 @@
           <a:p>
             <a:pPr algn="r"/>
             <a:r>
-              <a:rPr sz="1500" b="1">
+              <a:rPr sz="1400" b="1">
                 <a:solidFill>
                   <a:srgbClr val="10B981"/>
                 </a:solidFill>
                 <a:latin typeface="Calibri"/>
               </a:rPr>
-              <a:t>82%</a:t>
+              <a:t>98,6%</a:t>
             </a:r>
           </a:p>
         </p:txBody>
@@ -24951,8 +24951,148 @@
         </p:nvSpPr>
         <p:spPr>
           <a:xfrm>
+            <a:off x="822960" y="5074920"/>
+            <a:ext cx="3200400" cy="411480"/>
+          </a:xfrm>
+          <a:prstGeom prst="rect">
+            <a:avLst/>
+          </a:prstGeom>
+          <a:noFill/>
+        </p:spPr>
+        <p:txBody>
+          <a:bodyPr wrap="square" lIns="0" rIns="0" tIns="0" bIns="0" anchor="t">
+            <a:spAutoFit/>
+          </a:bodyPr>
+          <a:lstStyle/>
+          <a:p>
+            <a:pPr algn="l"/>
+            <a:r>
+              <a:rPr sz="1200" b="0">
+                <a:solidFill>
+                  <a:srgbClr val="1A1A2E"/>
+                </a:solidFill>
+                <a:latin typeface="Calibri"/>
+              </a:rPr>
+              <a:t>Операционная маржа</a:t>
+            </a:r>
+          </a:p>
+        </p:txBody>
+      </p:sp>
+      <p:sp>
+        <p:nvSpPr>
+          <p:cNvPr id="19" name="TextBox 18"/>
+          <p:cNvSpPr txBox="1"/>
+          <p:nvPr/>
+        </p:nvSpPr>
+        <p:spPr>
+          <a:xfrm>
+            <a:off x="4023360" y="5074920"/>
+            <a:ext cx="1828800" cy="411480"/>
+          </a:xfrm>
+          <a:prstGeom prst="rect">
+            <a:avLst/>
+          </a:prstGeom>
+          <a:noFill/>
+        </p:spPr>
+        <p:txBody>
+          <a:bodyPr wrap="square" lIns="0" rIns="0" tIns="0" bIns="0" anchor="t">
+            <a:spAutoFit/>
+          </a:bodyPr>
+          <a:lstStyle/>
+          <a:p>
+            <a:pPr algn="r"/>
+            <a:r>
+              <a:rPr sz="1400" b="1">
+                <a:solidFill>
+                  <a:srgbClr val="10B981"/>
+                </a:solidFill>
+                <a:latin typeface="Calibri"/>
+              </a:rPr>
+              <a:t>94,6%</a:t>
+            </a:r>
+          </a:p>
+        </p:txBody>
+      </p:sp>
+      <p:sp>
+        <p:nvSpPr>
+          <p:cNvPr id="20" name="TextBox 19"/>
+          <p:cNvSpPr txBox="1"/>
+          <p:nvPr/>
+        </p:nvSpPr>
+        <p:spPr>
+          <a:xfrm>
+            <a:off x="822960" y="5577840"/>
+            <a:ext cx="3200400" cy="411480"/>
+          </a:xfrm>
+          <a:prstGeom prst="rect">
+            <a:avLst/>
+          </a:prstGeom>
+          <a:noFill/>
+        </p:spPr>
+        <p:txBody>
+          <a:bodyPr wrap="square" lIns="0" rIns="0" tIns="0" bIns="0" anchor="t">
+            <a:spAutoFit/>
+          </a:bodyPr>
+          <a:lstStyle/>
+          <a:p>
+            <a:pPr algn="l"/>
+            <a:r>
+              <a:rPr sz="1200" b="0">
+                <a:solidFill>
+                  <a:srgbClr val="1A1A2E"/>
+                </a:solidFill>
+                <a:latin typeface="Calibri"/>
+              </a:rPr>
+              <a:t>Окупаемость клиента</a:t>
+            </a:r>
+          </a:p>
+        </p:txBody>
+      </p:sp>
+      <p:sp>
+        <p:nvSpPr>
+          <p:cNvPr id="21" name="TextBox 20"/>
+          <p:cNvSpPr txBox="1"/>
+          <p:nvPr/>
+        </p:nvSpPr>
+        <p:spPr>
+          <a:xfrm>
+            <a:off x="4023360" y="5577840"/>
+            <a:ext cx="1828800" cy="411480"/>
+          </a:xfrm>
+          <a:prstGeom prst="rect">
+            <a:avLst/>
+          </a:prstGeom>
+          <a:noFill/>
+        </p:spPr>
+        <p:txBody>
+          <a:bodyPr wrap="square" lIns="0" rIns="0" tIns="0" bIns="0" anchor="t">
+            <a:spAutoFit/>
+          </a:bodyPr>
+          <a:lstStyle/>
+          <a:p>
+            <a:pPr algn="r"/>
+            <a:r>
+              <a:rPr sz="1400" b="1">
+                <a:solidFill>
+                  <a:srgbClr val="10B981"/>
+                </a:solidFill>
+                <a:latin typeface="Calibri"/>
+              </a:rPr>
+              <a:t>0,6 мес</a:t>
+            </a:r>
+          </a:p>
+        </p:txBody>
+      </p:sp>
+      <p:sp>
+        <p:nvSpPr>
+          <p:cNvPr id="22" name="TextBox 21"/>
+          <p:cNvSpPr txBox="1"/>
+          <p:nvPr/>
+        </p:nvSpPr>
+        <p:spPr>
+          <a:xfrm>
             <a:off x="822960" y="5303520"/>
-            <a:ext cx="3200400" cy="457200"/>
+            <a:ext cx="5120640" cy="365760"/>
           </a:xfrm>
           <a:prstGeom prst="rect">
             <a:avLst/>
@@ -24967,27 +25107,62 @@
           <a:p>
             <a:pPr algn="l"/>
             <a:r>
-              <a:rPr sz="1300" b="0">
+              <a:rPr sz="1200" b="1">
                 <a:solidFill>
                   <a:srgbClr val="1A1A2E"/>
                 </a:solidFill>
                 <a:latin typeface="Calibri"/>
               </a:rPr>
-              <a:t>Окупаемость клиента</a:t>
-            </a:r>
-          </a:p>
-        </p:txBody>
-      </p:sp>
-      <p:sp>
-        <p:nvSpPr>
-          <p:cNvPr id="19" name="TextBox 18"/>
-          <p:cNvSpPr txBox="1"/>
-          <p:nvPr/>
-        </p:nvSpPr>
-        <p:spPr>
-          <a:xfrm>
-            <a:off x="4023360" y="5303520"/>
-            <a:ext cx="1828800" cy="457200"/>
+              <a:t>Затраты на 1 PRO клиента:</a:t>
+            </a:r>
+          </a:p>
+        </p:txBody>
+      </p:sp>
+      <p:sp>
+        <p:nvSpPr>
+          <p:cNvPr id="23" name="TextBox 22"/>
+          <p:cNvSpPr txBox="1"/>
+          <p:nvPr/>
+        </p:nvSpPr>
+        <p:spPr>
+          <a:xfrm>
+            <a:off x="822960" y="5760720"/>
+            <a:ext cx="3200400" cy="292608"/>
+          </a:xfrm>
+          <a:prstGeom prst="rect">
+            <a:avLst/>
+          </a:prstGeom>
+          <a:noFill/>
+        </p:spPr>
+        <p:txBody>
+          <a:bodyPr wrap="square" lIns="0" rIns="0" tIns="0" bIns="0" anchor="t">
+            <a:spAutoFit/>
+          </a:bodyPr>
+          <a:lstStyle/>
+          <a:p>
+            <a:pPr algn="l"/>
+            <a:r>
+              <a:rPr sz="1000" b="0">
+                <a:solidFill>
+                  <a:srgbClr val="5A6A7A"/>
+                </a:solidFill>
+                <a:latin typeface="Calibri"/>
+              </a:rPr>
+              <a:t>▸ Claude API (30 анализов)</a:t>
+            </a:r>
+          </a:p>
+        </p:txBody>
+      </p:sp>
+      <p:sp>
+        <p:nvSpPr>
+          <p:cNvPr id="24" name="TextBox 23"/>
+          <p:cNvSpPr txBox="1"/>
+          <p:nvPr/>
+        </p:nvSpPr>
+        <p:spPr>
+          <a:xfrm>
+            <a:off x="4023360" y="5760720"/>
+            <a:ext cx="1828800" cy="292608"/>
           </a:xfrm>
           <a:prstGeom prst="rect">
             <a:avLst/>
@@ -25002,20 +25177,370 @@
           <a:p>
             <a:pPr algn="r"/>
             <a:r>
-              <a:rPr sz="1500" b="1">
-                <a:solidFill>
-                  <a:srgbClr val="10B981"/>
-                </a:solidFill>
-                <a:latin typeface="Calibri"/>
-              </a:rPr>
-              <a:t>0,6 мес</a:t>
-            </a:r>
-          </a:p>
-        </p:txBody>
-      </p:sp>
-      <p:sp>
-        <p:nvSpPr>
-          <p:cNvPr id="20" name="Rounded Rectangle 19"/>
+              <a:rPr sz="1000" b="1">
+                <a:solidFill>
+                  <a:srgbClr val="E53E3E"/>
+                </a:solidFill>
+                <a:latin typeface="Calibri"/>
+              </a:rPr>
+              <a:t>24 ₽</a:t>
+            </a:r>
+          </a:p>
+        </p:txBody>
+      </p:sp>
+      <p:sp>
+        <p:nvSpPr>
+          <p:cNvPr id="25" name="TextBox 24"/>
+          <p:cNvSpPr txBox="1"/>
+          <p:nvPr/>
+        </p:nvSpPr>
+        <p:spPr>
+          <a:xfrm>
+            <a:off x="822960" y="6080760"/>
+            <a:ext cx="3200400" cy="292608"/>
+          </a:xfrm>
+          <a:prstGeom prst="rect">
+            <a:avLst/>
+          </a:prstGeom>
+          <a:noFill/>
+        </p:spPr>
+        <p:txBody>
+          <a:bodyPr wrap="square" lIns="0" rIns="0" tIns="0" bIns="0" anchor="t">
+            <a:spAutoFit/>
+          </a:bodyPr>
+          <a:lstStyle/>
+          <a:p>
+            <a:pPr algn="l"/>
+            <a:r>
+              <a:rPr sz="1000" b="0">
+                <a:solidFill>
+                  <a:srgbClr val="5A6A7A"/>
+                </a:solidFill>
+                <a:latin typeface="Calibri"/>
+              </a:rPr>
+              <a:t>▸ DaData</a:t>
+            </a:r>
+          </a:p>
+        </p:txBody>
+      </p:sp>
+      <p:sp>
+        <p:nvSpPr>
+          <p:cNvPr id="26" name="TextBox 25"/>
+          <p:cNvSpPr txBox="1"/>
+          <p:nvPr/>
+        </p:nvSpPr>
+        <p:spPr>
+          <a:xfrm>
+            <a:off x="4023360" y="6080760"/>
+            <a:ext cx="1828800" cy="292608"/>
+          </a:xfrm>
+          <a:prstGeom prst="rect">
+            <a:avLst/>
+          </a:prstGeom>
+          <a:noFill/>
+        </p:spPr>
+        <p:txBody>
+          <a:bodyPr wrap="square" lIns="0" rIns="0" tIns="0" bIns="0" anchor="t">
+            <a:spAutoFit/>
+          </a:bodyPr>
+          <a:lstStyle/>
+          <a:p>
+            <a:pPr algn="r"/>
+            <a:r>
+              <a:rPr sz="1000" b="1">
+                <a:solidFill>
+                  <a:srgbClr val="E53E3E"/>
+                </a:solidFill>
+                <a:latin typeface="Calibri"/>
+              </a:rPr>
+              <a:t>3 ₽</a:t>
+            </a:r>
+          </a:p>
+        </p:txBody>
+      </p:sp>
+      <p:sp>
+        <p:nvSpPr>
+          <p:cNvPr id="27" name="TextBox 26"/>
+          <p:cNvSpPr txBox="1"/>
+          <p:nvPr/>
+        </p:nvSpPr>
+        <p:spPr>
+          <a:xfrm>
+            <a:off x="822960" y="6400800"/>
+            <a:ext cx="3200400" cy="292608"/>
+          </a:xfrm>
+          <a:prstGeom prst="rect">
+            <a:avLst/>
+          </a:prstGeom>
+          <a:noFill/>
+        </p:spPr>
+        <p:txBody>
+          <a:bodyPr wrap="square" lIns="0" rIns="0" tIns="0" bIns="0" anchor="t">
+            <a:spAutoFit/>
+          </a:bodyPr>
+          <a:lstStyle/>
+          <a:p>
+            <a:pPr algn="l"/>
+            <a:r>
+              <a:rPr sz="1000" b="0">
+                <a:solidFill>
+                  <a:srgbClr val="5A6A7A"/>
+                </a:solidFill>
+                <a:latin typeface="Calibri"/>
+              </a:rPr>
+              <a:t>▸ Хостинг (Vercel+Neon)</a:t>
+            </a:r>
+          </a:p>
+        </p:txBody>
+      </p:sp>
+      <p:sp>
+        <p:nvSpPr>
+          <p:cNvPr id="28" name="TextBox 27"/>
+          <p:cNvSpPr txBox="1"/>
+          <p:nvPr/>
+        </p:nvSpPr>
+        <p:spPr>
+          <a:xfrm>
+            <a:off x="4023360" y="6400800"/>
+            <a:ext cx="1828800" cy="292608"/>
+          </a:xfrm>
+          <a:prstGeom prst="rect">
+            <a:avLst/>
+          </a:prstGeom>
+          <a:noFill/>
+        </p:spPr>
+        <p:txBody>
+          <a:bodyPr wrap="square" lIns="0" rIns="0" tIns="0" bIns="0" anchor="t">
+            <a:spAutoFit/>
+          </a:bodyPr>
+          <a:lstStyle/>
+          <a:p>
+            <a:pPr algn="r"/>
+            <a:r>
+              <a:rPr sz="1000" b="1">
+                <a:solidFill>
+                  <a:srgbClr val="E53E3E"/>
+                </a:solidFill>
+                <a:latin typeface="Calibri"/>
+              </a:rPr>
+              <a:t>0.32 ₽</a:t>
+            </a:r>
+          </a:p>
+        </p:txBody>
+      </p:sp>
+      <p:sp>
+        <p:nvSpPr>
+          <p:cNvPr id="29" name="TextBox 28"/>
+          <p:cNvSpPr txBox="1"/>
+          <p:nvPr/>
+        </p:nvSpPr>
+        <p:spPr>
+          <a:xfrm>
+            <a:off x="822960" y="6720840"/>
+            <a:ext cx="3200400" cy="292608"/>
+          </a:xfrm>
+          <a:prstGeom prst="rect">
+            <a:avLst/>
+          </a:prstGeom>
+          <a:noFill/>
+        </p:spPr>
+        <p:txBody>
+          <a:bodyPr wrap="square" lIns="0" rIns="0" tIns="0" bIns="0" anchor="t">
+            <a:spAutoFit/>
+          </a:bodyPr>
+          <a:lstStyle/>
+          <a:p>
+            <a:pPr algn="l"/>
+            <a:r>
+              <a:rPr sz="1000" b="0">
+                <a:solidFill>
+                  <a:srgbClr val="5A6A7A"/>
+                </a:solidFill>
+                <a:latin typeface="Calibri"/>
+              </a:rPr>
+              <a:t>▸ Генерация документов</a:t>
+            </a:r>
+          </a:p>
+        </p:txBody>
+      </p:sp>
+      <p:sp>
+        <p:nvSpPr>
+          <p:cNvPr id="30" name="TextBox 29"/>
+          <p:cNvSpPr txBox="1"/>
+          <p:nvPr/>
+        </p:nvSpPr>
+        <p:spPr>
+          <a:xfrm>
+            <a:off x="4023360" y="6720840"/>
+            <a:ext cx="1828800" cy="292608"/>
+          </a:xfrm>
+          <a:prstGeom prst="rect">
+            <a:avLst/>
+          </a:prstGeom>
+          <a:noFill/>
+        </p:spPr>
+        <p:txBody>
+          <a:bodyPr wrap="square" lIns="0" rIns="0" tIns="0" bIns="0" anchor="t">
+            <a:spAutoFit/>
+          </a:bodyPr>
+          <a:lstStyle/>
+          <a:p>
+            <a:pPr algn="r"/>
+            <a:r>
+              <a:rPr sz="1000" b="1">
+                <a:solidFill>
+                  <a:srgbClr val="E53E3E"/>
+                </a:solidFill>
+                <a:latin typeface="Calibri"/>
+              </a:rPr>
+              <a:t>0.5 ₽</a:t>
+            </a:r>
+          </a:p>
+        </p:txBody>
+      </p:sp>
+      <p:sp>
+        <p:nvSpPr>
+          <p:cNvPr id="31" name="TextBox 30"/>
+          <p:cNvSpPr txBox="1"/>
+          <p:nvPr/>
+        </p:nvSpPr>
+        <p:spPr>
+          <a:xfrm>
+            <a:off x="822960" y="7040880"/>
+            <a:ext cx="3200400" cy="292608"/>
+          </a:xfrm>
+          <a:prstGeom prst="rect">
+            <a:avLst/>
+          </a:prstGeom>
+          <a:noFill/>
+        </p:spPr>
+        <p:txBody>
+          <a:bodyPr wrap="square" lIns="0" rIns="0" tIns="0" bIns="0" anchor="t">
+            <a:spAutoFit/>
+          </a:bodyPr>
+          <a:lstStyle/>
+          <a:p>
+            <a:pPr algn="l"/>
+            <a:r>
+              <a:rPr sz="1000" b="0">
+                <a:solidFill>
+                  <a:srgbClr val="5A6A7A"/>
+                </a:solidFill>
+                <a:latin typeface="Calibri"/>
+              </a:rPr>
+              <a:t>▸ Платежи (2.5%)</a:t>
+            </a:r>
+          </a:p>
+        </p:txBody>
+      </p:sp>
+      <p:sp>
+        <p:nvSpPr>
+          <p:cNvPr id="32" name="TextBox 31"/>
+          <p:cNvSpPr txBox="1"/>
+          <p:nvPr/>
+        </p:nvSpPr>
+        <p:spPr>
+          <a:xfrm>
+            <a:off x="4023360" y="7040880"/>
+            <a:ext cx="1828800" cy="292608"/>
+          </a:xfrm>
+          <a:prstGeom prst="rect">
+            <a:avLst/>
+          </a:prstGeom>
+          <a:noFill/>
+        </p:spPr>
+        <p:txBody>
+          <a:bodyPr wrap="square" lIns="0" rIns="0" tIns="0" bIns="0" anchor="t">
+            <a:spAutoFit/>
+          </a:bodyPr>
+          <a:lstStyle/>
+          <a:p>
+            <a:pPr algn="r"/>
+            <a:r>
+              <a:rPr sz="1000" b="1">
+                <a:solidFill>
+                  <a:srgbClr val="E53E3E"/>
+                </a:solidFill>
+                <a:latin typeface="Calibri"/>
+              </a:rPr>
+              <a:t>50 ₽</a:t>
+            </a:r>
+          </a:p>
+        </p:txBody>
+      </p:sp>
+      <p:sp>
+        <p:nvSpPr>
+          <p:cNvPr id="33" name="TextBox 32"/>
+          <p:cNvSpPr txBox="1"/>
+          <p:nvPr/>
+        </p:nvSpPr>
+        <p:spPr>
+          <a:xfrm>
+            <a:off x="822960" y="7360920"/>
+            <a:ext cx="3200400" cy="292608"/>
+          </a:xfrm>
+          <a:prstGeom prst="rect">
+            <a:avLst/>
+          </a:prstGeom>
+          <a:noFill/>
+        </p:spPr>
+        <p:txBody>
+          <a:bodyPr wrap="square" lIns="0" rIns="0" tIns="0" bIns="0" anchor="t">
+            <a:spAutoFit/>
+          </a:bodyPr>
+          <a:lstStyle/>
+          <a:p>
+            <a:pPr algn="l"/>
+            <a:r>
+              <a:rPr sz="1000" b="0">
+                <a:solidFill>
+                  <a:srgbClr val="5A6A7A"/>
+                </a:solidFill>
+                <a:latin typeface="Calibri"/>
+              </a:rPr>
+              <a:t>▸ Поддержка</a:t>
+            </a:r>
+          </a:p>
+        </p:txBody>
+      </p:sp>
+      <p:sp>
+        <p:nvSpPr>
+          <p:cNvPr id="34" name="TextBox 33"/>
+          <p:cNvSpPr txBox="1"/>
+          <p:nvPr/>
+        </p:nvSpPr>
+        <p:spPr>
+          <a:xfrm>
+            <a:off x="4023360" y="7360920"/>
+            <a:ext cx="1828800" cy="292608"/>
+          </a:xfrm>
+          <a:prstGeom prst="rect">
+            <a:avLst/>
+          </a:prstGeom>
+          <a:noFill/>
+        </p:spPr>
+        <p:txBody>
+          <a:bodyPr wrap="square" lIns="0" rIns="0" tIns="0" bIns="0" anchor="t">
+            <a:spAutoFit/>
+          </a:bodyPr>
+          <a:lstStyle/>
+          <a:p>
+            <a:pPr algn="r"/>
+            <a:r>
+              <a:rPr sz="1000" b="1">
+                <a:solidFill>
+                  <a:srgbClr val="E53E3E"/>
+                </a:solidFill>
+                <a:latin typeface="Calibri"/>
+              </a:rPr>
+              <a:t>30 ₽</a:t>
+            </a:r>
+          </a:p>
+        </p:txBody>
+      </p:sp>
+      <p:sp>
+        <p:nvSpPr>
+          <p:cNvPr id="35" name="Rounded Rectangle 34"/>
           <p:cNvSpPr/>
           <p:nvPr/>
         </p:nvSpPr>
@@ -25061,7 +25586,7 @@
       </p:sp>
       <p:sp>
         <p:nvSpPr>
-          <p:cNvPr id="21" name="TextBox 20"/>
+          <p:cNvPr id="36" name="TextBox 35"/>
           <p:cNvSpPr txBox="1"/>
           <p:nvPr/>
         </p:nvSpPr>
@@ -25096,7 +25621,7 @@
       </p:sp>
       <p:sp>
         <p:nvSpPr>
-          <p:cNvPr id="22" name="Rectangle 21"/>
+          <p:cNvPr id="37" name="Rectangle 36"/>
           <p:cNvSpPr/>
           <p:nvPr/>
         </p:nvSpPr>
@@ -25140,7 +25665,7 @@
       </p:sp>
       <p:sp>
         <p:nvSpPr>
-          <p:cNvPr id="23" name="TextBox 22"/>
+          <p:cNvPr id="38" name="TextBox 37"/>
           <p:cNvSpPr txBox="1"/>
           <p:nvPr/>
         </p:nvSpPr>
@@ -25175,7 +25700,7 @@
       </p:sp>
       <p:sp>
         <p:nvSpPr>
-          <p:cNvPr id="24" name="TextBox 23"/>
+          <p:cNvPr id="39" name="TextBox 38"/>
           <p:cNvSpPr txBox="1"/>
           <p:nvPr/>
         </p:nvSpPr>
@@ -25210,7 +25735,7 @@
       </p:sp>
       <p:sp>
         <p:nvSpPr>
-          <p:cNvPr id="25" name="Rectangle 24"/>
+          <p:cNvPr id="40" name="Rectangle 39"/>
           <p:cNvSpPr/>
           <p:nvPr/>
         </p:nvSpPr>
@@ -25254,7 +25779,7 @@
       </p:sp>
       <p:sp>
         <p:nvSpPr>
-          <p:cNvPr id="26" name="TextBox 25"/>
+          <p:cNvPr id="41" name="TextBox 40"/>
           <p:cNvSpPr txBox="1"/>
           <p:nvPr/>
         </p:nvSpPr>
@@ -25289,7 +25814,7 @@
       </p:sp>
       <p:sp>
         <p:nvSpPr>
-          <p:cNvPr id="27" name="TextBox 26"/>
+          <p:cNvPr id="42" name="TextBox 41"/>
           <p:cNvSpPr txBox="1"/>
           <p:nvPr/>
         </p:nvSpPr>
@@ -25324,7 +25849,7 @@
       </p:sp>
       <p:sp>
         <p:nvSpPr>
-          <p:cNvPr id="28" name="Rectangle 27"/>
+          <p:cNvPr id="43" name="Rectangle 42"/>
           <p:cNvSpPr/>
           <p:nvPr/>
         </p:nvSpPr>
@@ -25368,7 +25893,7 @@
       </p:sp>
       <p:sp>
         <p:nvSpPr>
-          <p:cNvPr id="29" name="TextBox 28"/>
+          <p:cNvPr id="44" name="TextBox 43"/>
           <p:cNvSpPr txBox="1"/>
           <p:nvPr/>
         </p:nvSpPr>
@@ -25403,7 +25928,7 @@
       </p:sp>
       <p:sp>
         <p:nvSpPr>
-          <p:cNvPr id="30" name="TextBox 29"/>
+          <p:cNvPr id="45" name="TextBox 44"/>
           <p:cNvSpPr txBox="1"/>
           <p:nvPr/>
         </p:nvSpPr>
@@ -25438,7 +25963,7 @@
       </p:sp>
       <p:sp>
         <p:nvSpPr>
-          <p:cNvPr id="31" name="Rectangle 30"/>
+          <p:cNvPr id="46" name="Rectangle 45"/>
           <p:cNvSpPr/>
           <p:nvPr/>
         </p:nvSpPr>
@@ -25482,7 +26007,7 @@
       </p:sp>
       <p:sp>
         <p:nvSpPr>
-          <p:cNvPr id="32" name="TextBox 31"/>
+          <p:cNvPr id="47" name="TextBox 46"/>
           <p:cNvSpPr txBox="1"/>
           <p:nvPr/>
         </p:nvSpPr>
@@ -25517,7 +26042,7 @@
       </p:sp>
       <p:sp>
         <p:nvSpPr>
-          <p:cNvPr id="33" name="TextBox 32"/>
+          <p:cNvPr id="48" name="TextBox 47"/>
           <p:cNvSpPr txBox="1"/>
           <p:nvPr/>
         </p:nvSpPr>

</xml_diff>